<commit_message>
Adjust presentation text separators
Co-authored-by: Ray-Liu-intel <220123272+Ray-Liu-intel@users.noreply.github.com>
</commit_message>
<xml_diff>
--- a/presentations/miniops/MiniOps_Management_CN.pptx
+++ b/presentations/miniops/MiniOps_Management_CN.pptx
@@ -4303,7 +4303,7 @@
                 </a:solidFill>
                 <a:latin typeface="Microsoft YaHei"/>
               </a:rPr>
-              <a:t>Ray Liu | September 2026</a:t>
+              <a:t>Ray Liu · September 2026</a:t>
             </a:r>
           </a:p>
         </p:txBody>
@@ -5477,7 +5477,7 @@
                 </a:solidFill>
                 <a:latin typeface="Microsoft YaHei"/>
               </a:rPr>
-              <a:t>Ray Liu | September 2026</a:t>
+              <a:t>Ray Liu · September 2026</a:t>
             </a:r>
           </a:p>
         </p:txBody>
@@ -6460,7 +6460,7 @@
                 </a:solidFill>
                 <a:latin typeface="Microsoft YaHei"/>
               </a:rPr>
-              <a:t>Ray Liu | September 2026</a:t>
+              <a:t>Ray Liu · September 2026</a:t>
             </a:r>
           </a:p>
         </p:txBody>
@@ -7547,7 +7547,7 @@
                 </a:solidFill>
                 <a:latin typeface="Microsoft YaHei"/>
               </a:rPr>
-              <a:t>Ray Liu | September 2026</a:t>
+              <a:t>Ray Liu · September 2026</a:t>
             </a:r>
           </a:p>
         </p:txBody>
@@ -8530,7 +8530,7 @@
                 </a:solidFill>
                 <a:latin typeface="Microsoft YaHei"/>
               </a:rPr>
-              <a:t>Ray Liu | September 2026</a:t>
+              <a:t>Ray Liu · September 2026</a:t>
             </a:r>
           </a:p>
         </p:txBody>
@@ -9322,7 +9322,7 @@
                 </a:solidFill>
                 <a:latin typeface="Microsoft YaHei"/>
               </a:rPr>
-              <a:t>Ray Liu | September 2026</a:t>
+              <a:t>Ray Liu · September 2026</a:t>
             </a:r>
           </a:p>
         </p:txBody>

</xml_diff>

<commit_message>
Add presentation tests and font checks
Co-authored-by: Ray-Liu-intel <220123272+Ray-Liu-intel@users.noreply.github.com>
</commit_message>
<xml_diff>
--- a/presentations/miniops/MiniOps_Management_CN.pptx
+++ b/presentations/miniops/MiniOps_Management_CN.pptx
@@ -4174,7 +4174,7 @@
                 <a:solidFill>
                   <a:srgbClr val="FFFFFF"/>
                 </a:solidFill>
-                <a:latin typeface="Microsoft YaHei"/>
+                <a:latin typeface="Noto Sans CJK SC"/>
               </a:rPr>
               <a:t>测试工程自动化：交付成果与业务价值</a:t>
             </a:r>
@@ -4216,7 +4216,7 @@
                 <a:solidFill>
                   <a:srgbClr val="DCE9F7"/>
                 </a:solidFill>
-                <a:latin typeface="Microsoft YaHei"/>
+                <a:latin typeface="Noto Sans CJK SC"/>
               </a:rPr>
               <a:t>MiniOps 管理层汇报｜10 分钟｜双语可编辑交付物</a:t>
             </a:r>
@@ -4301,7 +4301,7 @@
                 <a:solidFill>
                   <a:srgbClr val="5A6573"/>
                 </a:solidFill>
-                <a:latin typeface="Microsoft YaHei"/>
+                <a:latin typeface="Noto Sans CJK SC"/>
               </a:rPr>
               <a:t>Ray Liu · September 2026</a:t>
             </a:r>
@@ -4343,7 +4343,7 @@
                 <a:solidFill>
                   <a:srgbClr val="5A6573"/>
                 </a:solidFill>
-                <a:latin typeface="Microsoft YaHei"/>
+                <a:latin typeface="Noto Sans CJK SC"/>
               </a:rPr>
               <a:t>1</a:t>
             </a:r>
@@ -4430,7 +4430,7 @@
                 <a:solidFill>
                   <a:srgbClr val="092540"/>
                 </a:solidFill>
-                <a:latin typeface="Microsoft YaHei"/>
+                <a:latin typeface="Noto Sans CJK SC"/>
               </a:rPr>
               <a:t>四个工具已交付；下一步是验证团队级价值，而不是提前宣称收益数字。</a:t>
             </a:r>
@@ -4560,7 +4560,7 @@
                 <a:solidFill>
                   <a:srgbClr val="092540"/>
                 </a:solidFill>
-                <a:latin typeface="Microsoft YaHei"/>
+                <a:latin typeface="Noto Sans CJK SC"/>
               </a:rPr>
               <a:t>可视化配置生成</a:t>
             </a:r>
@@ -4602,7 +4602,7 @@
                 <a:solidFill>
                   <a:srgbClr val="1E293B"/>
                 </a:solidFill>
-                <a:latin typeface="Microsoft YaHei"/>
+                <a:latin typeface="Noto Sans CJK SC"/>
               </a:rPr>
               <a:t>PCAR3 Web UI 生成 Python 配置</a:t>
             </a:r>
@@ -4621,7 +4621,7 @@
                 <a:solidFill>
                   <a:srgbClr val="1E293B"/>
                 </a:solidFill>
-                <a:latin typeface="Microsoft YaHei"/>
+                <a:latin typeface="Noto Sans CJK SC"/>
               </a:rPr>
               <a:t>支持多 PLB、Loop Partition、条件结构</a:t>
             </a:r>
@@ -4751,7 +4751,7 @@
                 <a:solidFill>
                   <a:srgbClr val="092540"/>
                 </a:solidFill>
-                <a:latin typeface="Microsoft YaHei"/>
+                <a:latin typeface="Noto Sans CJK SC"/>
               </a:rPr>
               <a:t>自然语言 / 构建辅助</a:t>
             </a:r>
@@ -4793,7 +4793,7 @@
                 <a:solidFill>
                   <a:srgbClr val="1E293B"/>
                 </a:solidFill>
-                <a:latin typeface="Microsoft YaHei"/>
+                <a:latin typeface="Noto Sans CJK SC"/>
               </a:rPr>
               <a:t>Copilot Skill 生成 .pcar</a:t>
             </a:r>
@@ -4812,7 +4812,7 @@
                 <a:solidFill>
                   <a:srgbClr val="1E293B"/>
                 </a:solidFill>
-                <a:latin typeface="Microsoft YaHei"/>
+                <a:latin typeface="Noto Sans CJK SC"/>
               </a:rPr>
               <a:t>可选查询 Pattern、提交构建并检查真实 Pat 输出</a:t>
             </a:r>
@@ -4942,7 +4942,7 @@
                 <a:solidFill>
                   <a:srgbClr val="092540"/>
                 </a:solidFill>
-                <a:latin typeface="Microsoft YaHei"/>
+                <a:latin typeface="Noto Sans CJK SC"/>
               </a:rPr>
               <a:t>DVS 预处理</a:t>
             </a:r>
@@ -4984,7 +4984,7 @@
                 <a:solidFill>
                   <a:srgbClr val="1E293B"/>
                 </a:solidFill>
-                <a:latin typeface="Microsoft YaHei"/>
+                <a:latin typeface="Noto Sans CJK SC"/>
               </a:rPr>
               <a:t>CLI / Skill 处理 16 个 trigger 块</a:t>
             </a:r>
@@ -5003,7 +5003,7 @@
                 <a:solidFill>
                   <a:srgbClr val="1E293B"/>
                 </a:solidFill>
-                <a:latin typeface="Microsoft YaHei"/>
+                <a:latin typeface="Noto Sans CJK SC"/>
               </a:rPr>
               <a:t>支持 CCD / IOD / DRD，保留源文件</a:t>
             </a:r>
@@ -5133,7 +5133,7 @@
                 <a:solidFill>
                   <a:srgbClr val="092540"/>
                 </a:solidFill>
-                <a:latin typeface="Microsoft YaHei"/>
+                <a:latin typeface="Noto Sans CJK SC"/>
               </a:rPr>
               <a:t>Scan Pin 检查</a:t>
             </a:r>
@@ -5175,7 +5175,7 @@
                 <a:solidFill>
                   <a:srgbClr val="1E293B"/>
                 </a:solidFill>
-                <a:latin typeface="Microsoft YaHei"/>
+                <a:latin typeface="Noto Sans CJK SC"/>
               </a:rPr>
               <a:t>只读提取 ScanIn / ScanOut</a:t>
             </a:r>
@@ -5194,7 +5194,7 @@
                 <a:solidFill>
                   <a:srgbClr val="1E293B"/>
                 </a:solidFill>
-                <a:latin typeface="Microsoft YaHei"/>
+                <a:latin typeface="Noto Sans CJK SC"/>
               </a:rPr>
               <a:t>输出可追踪 JSON 报告用于人工复核</a:t>
             </a:r>
@@ -5348,7 +5348,7 @@
                 <a:solidFill>
                   <a:srgbClr val="FFFFFF"/>
                 </a:solidFill>
-                <a:latin typeface="Microsoft YaHei"/>
+                <a:latin typeface="Noto Sans CJK SC"/>
               </a:rPr>
               <a:t>解决的问题</a:t>
             </a:r>
@@ -5390,7 +5390,7 @@
                 <a:solidFill>
                   <a:srgbClr val="DCE9F7"/>
                 </a:solidFill>
-                <a:latin typeface="Microsoft YaHei"/>
+                <a:latin typeface="Noto Sans CJK SC"/>
               </a:rPr>
               <a:t>把重复规则工作转换为更一致、可复核的执行方式</a:t>
             </a:r>
@@ -5475,7 +5475,7 @@
                 <a:solidFill>
                   <a:srgbClr val="5A6573"/>
                 </a:solidFill>
-                <a:latin typeface="Microsoft YaHei"/>
+                <a:latin typeface="Noto Sans CJK SC"/>
               </a:rPr>
               <a:t>Ray Liu · September 2026</a:t>
             </a:r>
@@ -5517,7 +5517,7 @@
                 <a:solidFill>
                   <a:srgbClr val="5A6573"/>
                 </a:solidFill>
-                <a:latin typeface="Microsoft YaHei"/>
+                <a:latin typeface="Noto Sans CJK SC"/>
               </a:rPr>
               <a:t>2</a:t>
             </a:r>
@@ -5647,7 +5647,7 @@
                 <a:solidFill>
                   <a:srgbClr val="092540"/>
                 </a:solidFill>
-                <a:latin typeface="Microsoft YaHei"/>
+                <a:latin typeface="Noto Sans CJK SC"/>
               </a:rPr>
               <a:t>重复的配置组织</a:t>
             </a:r>
@@ -5689,7 +5689,7 @@
                 <a:solidFill>
                   <a:srgbClr val="1E293B"/>
                 </a:solidFill>
-                <a:latin typeface="Microsoft YaHei"/>
+                <a:latin typeface="Noto Sans CJK SC"/>
               </a:rPr>
               <a:t>重复 PLB / Pattern / 条件配置</a:t>
             </a:r>
@@ -5708,7 +5708,7 @@
                 <a:solidFill>
                   <a:srgbClr val="1E293B"/>
                 </a:solidFill>
-                <a:latin typeface="Microsoft YaHei"/>
+                <a:latin typeface="Noto Sans CJK SC"/>
               </a:rPr>
               <a:t>对应方式：可视化或自然语言生成，减少重复结构录入</a:t>
             </a:r>
@@ -5838,7 +5838,7 @@
                 <a:solidFill>
                   <a:srgbClr val="092540"/>
                 </a:solidFill>
-                <a:latin typeface="Microsoft YaHei"/>
+                <a:latin typeface="Noto Sans CJK SC"/>
               </a:rPr>
               <a:t>复杂且易错的规则</a:t>
             </a:r>
@@ -5880,7 +5880,7 @@
                 <a:solidFill>
                   <a:srgbClr val="1E293B"/>
                 </a:solidFill>
-                <a:latin typeface="Microsoft YaHei"/>
+                <a:latin typeface="Noto Sans CJK SC"/>
               </a:rPr>
               <a:t>DVS cycle / trigger / pin 规则多</a:t>
             </a:r>
@@ -5899,7 +5899,7 @@
                 <a:solidFill>
                   <a:srgbClr val="1E293B"/>
                 </a:solidFill>
-                <a:latin typeface="Microsoft YaHei"/>
+                <a:latin typeface="Noto Sans CJK SC"/>
               </a:rPr>
               <a:t>对应方式：参数化处理和输入检查，避免静默偏差</a:t>
             </a:r>
@@ -6029,7 +6029,7 @@
                 <a:solidFill>
                   <a:srgbClr val="092540"/>
                 </a:solidFill>
-                <a:latin typeface="Microsoft YaHei"/>
+                <a:latin typeface="Noto Sans CJK SC"/>
               </a:rPr>
               <a:t>重复的只读检查</a:t>
             </a:r>
@@ -6071,7 +6071,7 @@
                 <a:solidFill>
                   <a:srgbClr val="1E293B"/>
                 </a:solidFill>
-                <a:latin typeface="Microsoft YaHei"/>
+                <a:latin typeface="Noto Sans CJK SC"/>
               </a:rPr>
               <a:t>反复做 scan-pin 提取和 group 对比</a:t>
             </a:r>
@@ -6090,7 +6090,7 @@
                 <a:solidFill>
                   <a:srgbClr val="1E293B"/>
                 </a:solidFill>
-                <a:latin typeface="Microsoft YaHei"/>
+                <a:latin typeface="Noto Sans CJK SC"/>
               </a:rPr>
               <a:t>对应方式：结构化检查结果和可追踪报告</a:t>
             </a:r>
@@ -6177,7 +6177,7 @@
                 <a:solidFill>
                   <a:srgbClr val="092540"/>
                 </a:solidFill>
-                <a:latin typeface="Microsoft YaHei"/>
+                <a:latin typeface="Noto Sans CJK SC"/>
               </a:rPr>
               <a:t>这些是任务特征，而不是已量化的历史损失；自动化支持工程判断，而不替代工程判断。</a:t>
             </a:r>
@@ -6331,7 +6331,7 @@
                 <a:solidFill>
                   <a:srgbClr val="FFFFFF"/>
                 </a:solidFill>
-                <a:latin typeface="Microsoft YaHei"/>
+                <a:latin typeface="Noto Sans CJK SC"/>
               </a:rPr>
               <a:t>主要交付成果</a:t>
             </a:r>
@@ -6373,7 +6373,7 @@
                 <a:solidFill>
                   <a:srgbClr val="DCE9F7"/>
                 </a:solidFill>
-                <a:latin typeface="Microsoft YaHei"/>
+                <a:latin typeface="Noto Sans CJK SC"/>
               </a:rPr>
               <a:t>每项交付都区分“已交付能力”和“预期价值”</a:t>
             </a:r>
@@ -6458,7 +6458,7 @@
                 <a:solidFill>
                   <a:srgbClr val="5A6573"/>
                 </a:solidFill>
-                <a:latin typeface="Microsoft YaHei"/>
+                <a:latin typeface="Noto Sans CJK SC"/>
               </a:rPr>
               <a:t>Ray Liu · September 2026</a:t>
             </a:r>
@@ -6500,7 +6500,7 @@
                 <a:solidFill>
                   <a:srgbClr val="5A6573"/>
                 </a:solidFill>
-                <a:latin typeface="Microsoft YaHei"/>
+                <a:latin typeface="Noto Sans CJK SC"/>
               </a:rPr>
               <a:t>3</a:t>
             </a:r>
@@ -6630,7 +6630,7 @@
                 <a:solidFill>
                   <a:srgbClr val="092540"/>
                 </a:solidFill>
-                <a:latin typeface="Microsoft YaHei"/>
+                <a:latin typeface="Noto Sans CJK SC"/>
               </a:rPr>
               <a:t>A. PCAR3 可视化 Web UI</a:t>
             </a:r>
@@ -6672,7 +6672,7 @@
                 <a:solidFill>
                   <a:srgbClr val="1E293B"/>
                 </a:solidFill>
-                <a:latin typeface="Microsoft YaHei"/>
+                <a:latin typeface="Noto Sans CJK SC"/>
               </a:rPr>
               <a:t>已交付：多 PLB、Loop Partition、拖拽排序、状态持久化</a:t>
             </a:r>
@@ -6691,7 +6691,7 @@
                 <a:solidFill>
                   <a:srgbClr val="1E293B"/>
                 </a:solidFill>
-                <a:latin typeface="Microsoft YaHei"/>
+                <a:latin typeface="Noto Sans CJK SC"/>
               </a:rPr>
               <a:t>预期价值：减少手工结构整理与重复录入</a:t>
             </a:r>
@@ -6821,7 +6821,7 @@
                 <a:solidFill>
                   <a:srgbClr val="092540"/>
                 </a:solidFill>
-                <a:latin typeface="Microsoft YaHei"/>
+                <a:latin typeface="Noto Sans CJK SC"/>
               </a:rPr>
               <a:t>B. 自然语言 Copilot Skill</a:t>
             </a:r>
@@ -6863,7 +6863,7 @@
                 <a:solidFill>
                   <a:srgbClr val="1E293B"/>
                 </a:solidFill>
-                <a:latin typeface="Microsoft YaHei"/>
+                <a:latin typeface="Noto Sans CJK SC"/>
               </a:rPr>
               <a:t>已交付：生成 .pcar；可选解析 Pattern、提交构建、轮询状态并检查真实 Pat 输出</a:t>
             </a:r>
@@ -6882,7 +6882,7 @@
                 <a:solidFill>
                   <a:srgbClr val="1E293B"/>
                 </a:solidFill>
-                <a:latin typeface="Microsoft YaHei"/>
+                <a:latin typeface="Noto Sans CJK SC"/>
               </a:rPr>
               <a:t>边界：构建依赖合适环境与访问权限；仅代码生成不依赖构建环境</a:t>
             </a:r>
@@ -7012,7 +7012,7 @@
                 <a:solidFill>
                   <a:srgbClr val="092540"/>
                 </a:solidFill>
-                <a:latin typeface="Microsoft YaHei"/>
+                <a:latin typeface="Noto Sans CJK SC"/>
               </a:rPr>
               <a:t>C. DVS CLI / Skill</a:t>
             </a:r>
@@ -7054,7 +7054,7 @@
                 <a:solidFill>
                   <a:srgbClr val="1E293B"/>
                 </a:solidFill>
-                <a:latin typeface="Microsoft YaHei"/>
+                <a:latin typeface="Noto Sans CJK SC"/>
               </a:rPr>
               <a:t>已交付：转换预期 16 个 trigger 块，支持 CCD / IOD / DRD 与 .stil / .stil.gz</a:t>
             </a:r>
@@ -7073,7 +7073,7 @@
                 <a:solidFill>
                   <a:srgbClr val="1E293B"/>
                 </a:solidFill>
-                <a:latin typeface="Microsoft YaHei"/>
+                <a:latin typeface="Noto Sans CJK SC"/>
               </a:rPr>
               <a:t>预期价值：让重复编辑变成规则一致的文件处理</a:t>
             </a:r>
@@ -7203,7 +7203,7 @@
                 <a:solidFill>
                   <a:srgbClr val="092540"/>
                 </a:solidFill>
-                <a:latin typeface="Microsoft YaHei"/>
+                <a:latin typeface="Noto Sans CJK SC"/>
               </a:rPr>
               <a:t>D. Scan Pin CLI / Skill</a:t>
             </a:r>
@@ -7245,7 +7245,7 @@
                 <a:solidFill>
                   <a:srgbClr val="1E293B"/>
                 </a:solidFill>
-                <a:latin typeface="Microsoft YaHei"/>
+                <a:latin typeface="Noto Sans CJK SC"/>
               </a:rPr>
               <a:t>已交付：提取 ScanIn / ScanOut、标准化名称、检查 allowed group union、输出含链名/行号/匹配组的 JSON</a:t>
             </a:r>
@@ -7264,7 +7264,7 @@
                 <a:solidFill>
                   <a:srgbClr val="1E293B"/>
                 </a:solidFill>
-                <a:latin typeface="Microsoft YaHei"/>
+                <a:latin typeface="Noto Sans CJK SC"/>
               </a:rPr>
               <a:t>预期价值：提供可追踪的只读检查结果，便于人工复核</a:t>
             </a:r>
@@ -7418,7 +7418,7 @@
                 <a:solidFill>
                   <a:srgbClr val="FFFFFF"/>
                 </a:solidFill>
-                <a:latin typeface="Microsoft YaHei"/>
+                <a:latin typeface="Noto Sans CJK SC"/>
               </a:rPr>
               <a:t>质量与风险控制</a:t>
             </a:r>
@@ -7460,7 +7460,7 @@
                 <a:solidFill>
                   <a:srgbClr val="DCE9F7"/>
                 </a:solidFill>
-                <a:latin typeface="Microsoft YaHei"/>
+                <a:latin typeface="Noto Sans CJK SC"/>
               </a:rPr>
               <a:t>强调输入保护、产物核对和边界说明，而不是过度承诺</a:t>
             </a:r>
@@ -7545,7 +7545,7 @@
                 <a:solidFill>
                   <a:srgbClr val="5A6573"/>
                 </a:solidFill>
-                <a:latin typeface="Microsoft YaHei"/>
+                <a:latin typeface="Noto Sans CJK SC"/>
               </a:rPr>
               <a:t>Ray Liu · September 2026</a:t>
             </a:r>
@@ -7587,7 +7587,7 @@
                 <a:solidFill>
                   <a:srgbClr val="5A6573"/>
                 </a:solidFill>
-                <a:latin typeface="Microsoft YaHei"/>
+                <a:latin typeface="Noto Sans CJK SC"/>
               </a:rPr>
               <a:t>4</a:t>
             </a:r>
@@ -7717,7 +7717,7 @@
                 <a:solidFill>
                   <a:srgbClr val="092540"/>
                 </a:solidFill>
-                <a:latin typeface="Microsoft YaHei"/>
+                <a:latin typeface="Noto Sans CJK SC"/>
               </a:rPr>
               <a:t>保护输入</a:t>
             </a:r>
@@ -7759,7 +7759,7 @@
                 <a:solidFill>
                   <a:srgbClr val="1E293B"/>
                 </a:solidFill>
-                <a:latin typeface="Microsoft YaHei"/>
+                <a:latin typeface="Noto Sans CJK SC"/>
               </a:rPr>
               <a:t>DVS 单独输出新文件，不覆盖源文件</a:t>
             </a:r>
@@ -7778,7 +7778,7 @@
                 <a:solidFill>
                   <a:srgbClr val="1E293B"/>
                 </a:solidFill>
-                <a:latin typeface="Microsoft YaHei"/>
+                <a:latin typeface="Noto Sans CJK SC"/>
               </a:rPr>
               <a:t>支持 dry-run，并拒绝异常、重复处理或会覆盖源文件的输入</a:t>
             </a:r>
@@ -7908,7 +7908,7 @@
                 <a:solidFill>
                   <a:srgbClr val="092540"/>
                 </a:solidFill>
-                <a:latin typeface="Microsoft YaHei"/>
+                <a:latin typeface="Noto Sans CJK SC"/>
               </a:rPr>
               <a:t>核对产物</a:t>
             </a:r>
@@ -7950,7 +7950,7 @@
                 <a:solidFill>
                   <a:srgbClr val="1E293B"/>
                 </a:solidFill>
-                <a:latin typeface="Microsoft YaHei"/>
+                <a:latin typeface="Noto Sans CJK SC"/>
               </a:rPr>
               <a:t>PList 关注真实 Pat 内容，而不仅是任务完成状态</a:t>
             </a:r>
@@ -7969,7 +7969,7 @@
                 <a:solidFill>
                   <a:srgbClr val="1E293B"/>
                 </a:solidFill>
-                <a:latin typeface="Microsoft YaHei"/>
+                <a:latin typeface="Noto Sans CJK SC"/>
               </a:rPr>
               <a:t>Scan pin 检查输出链名、行号和匹配组，便于追踪</a:t>
             </a:r>
@@ -8099,7 +8099,7 @@
                 <a:solidFill>
                   <a:srgbClr val="092540"/>
                 </a:solidFill>
-                <a:latin typeface="Microsoft YaHei"/>
+                <a:latin typeface="Noto Sans CJK SC"/>
               </a:rPr>
               <a:t>明确边界</a:t>
             </a:r>
@@ -8141,7 +8141,7 @@
                 <a:solidFill>
                   <a:srgbClr val="1E293B"/>
                 </a:solidFill>
-                <a:latin typeface="Microsoft YaHei"/>
+                <a:latin typeface="Noto Sans CJK SC"/>
               </a:rPr>
               <a:t>Pin PASS 只代表属于允许 group union</a:t>
             </a:r>
@@ -8160,7 +8160,7 @@
                 <a:solidFill>
                   <a:srgbClr val="1E293B"/>
                 </a:solidFill>
-                <a:latin typeface="Microsoft YaHei"/>
+                <a:latin typeface="Noto Sans CJK SC"/>
               </a:rPr>
               <a:t>不代表方向、时序、电气正确性或 tester readiness</a:t>
             </a:r>
@@ -8247,7 +8247,7 @@
                 <a:solidFill>
                   <a:srgbClr val="092540"/>
                 </a:solidFill>
-                <a:latin typeface="Microsoft YaHei"/>
+                <a:latin typeface="Noto Sans CJK SC"/>
               </a:rPr>
               <a:t>不宣称零缺陷或生产认证；最终接收与异常处置仍由人工负责。</a:t>
             </a:r>
@@ -8401,7 +8401,7 @@
                 <a:solidFill>
                   <a:srgbClr val="FFFFFF"/>
                 </a:solidFill>
-                <a:latin typeface="Microsoft YaHei"/>
+                <a:latin typeface="Noto Sans CJK SC"/>
               </a:rPr>
               <a:t>业务价值与衡量方式</a:t>
             </a:r>
@@ -8443,7 +8443,7 @@
                 <a:solidFill>
                   <a:srgbClr val="DCE9F7"/>
                 </a:solidFill>
-                <a:latin typeface="Microsoft YaHei"/>
+                <a:latin typeface="Noto Sans CJK SC"/>
               </a:rPr>
               <a:t>先定义测量口径，再讨论是否具备推广价值</a:t>
             </a:r>
@@ -8528,7 +8528,7 @@
                 <a:solidFill>
                   <a:srgbClr val="5A6573"/>
                 </a:solidFill>
-                <a:latin typeface="Microsoft YaHei"/>
+                <a:latin typeface="Noto Sans CJK SC"/>
               </a:rPr>
               <a:t>Ray Liu · September 2026</a:t>
             </a:r>
@@ -8570,7 +8570,7 @@
                 <a:solidFill>
                   <a:srgbClr val="5A6573"/>
                 </a:solidFill>
-                <a:latin typeface="Microsoft YaHei"/>
+                <a:latin typeface="Noto Sans CJK SC"/>
               </a:rPr>
               <a:t>5</a:t>
             </a:r>
@@ -8612,7 +8612,7 @@
                           <a:solidFill>
                             <a:srgbClr val="FFFFFF"/>
                           </a:solidFill>
-                          <a:latin typeface="Microsoft YaHei"/>
+                          <a:latin typeface="Noto Sans CJK SC"/>
                         </a:rPr>
                         <a:t>维度</a:t>
                       </a:r>
@@ -8635,7 +8635,7 @@
                           <a:solidFill>
                             <a:srgbClr val="FFFFFF"/>
                           </a:solidFill>
-                          <a:latin typeface="Microsoft YaHei"/>
+                          <a:latin typeface="Noto Sans CJK SC"/>
                         </a:rPr>
                         <a:t>建议指标</a:t>
                       </a:r>
@@ -8658,7 +8658,7 @@
                           <a:solidFill>
                             <a:srgbClr val="FFFFFF"/>
                           </a:solidFill>
-                          <a:latin typeface="Microsoft YaHei"/>
+                          <a:latin typeface="Noto Sans CJK SC"/>
                         </a:rPr>
                         <a:t>评估方式</a:t>
                       </a:r>
@@ -8683,7 +8683,7 @@
                           <a:solidFill>
                             <a:srgbClr val="1E293B"/>
                           </a:solidFill>
-                          <a:latin typeface="Microsoft YaHei"/>
+                          <a:latin typeface="Noto Sans CJK SC"/>
                         </a:rPr>
                         <a:t>效率</a:t>
                       </a:r>
@@ -8706,7 +8706,7 @@
                           <a:solidFill>
                             <a:srgbClr val="1E293B"/>
                           </a:solidFill>
-                          <a:latin typeface="Microsoft YaHei"/>
+                          <a:latin typeface="Noto Sans CJK SC"/>
                         </a:rPr>
                         <a:t>同类任务的人工作业时间</a:t>
                       </a:r>
@@ -8729,7 +8729,7 @@
                           <a:solidFill>
                             <a:srgbClr val="1E293B"/>
                           </a:solidFill>
-                          <a:latin typeface="Microsoft YaHei"/>
+                          <a:latin typeface="Noto Sans CJK SC"/>
                         </a:rPr>
                         <a:t>比较等价的人工/工具流程，包含准备、复核、纠错；机器等待单独记录</a:t>
                       </a:r>
@@ -8754,7 +8754,7 @@
                           <a:solidFill>
                             <a:srgbClr val="1E293B"/>
                           </a:solidFill>
-                          <a:latin typeface="Microsoft YaHei"/>
+                          <a:latin typeface="Noto Sans CJK SC"/>
                         </a:rPr>
                         <a:t>质量</a:t>
                       </a:r>
@@ -8777,7 +8777,7 @@
                           <a:solidFill>
                             <a:srgbClr val="1E293B"/>
                           </a:solidFill>
-                          <a:latin typeface="Microsoft YaHei"/>
+                          <a:latin typeface="Noto Sans CJK SC"/>
                         </a:rPr>
                         <a:t>返工与评审发现</a:t>
                       </a:r>
@@ -8800,7 +8800,7 @@
                           <a:solidFill>
                             <a:srgbClr val="1E293B"/>
                           </a:solidFill>
-                          <a:latin typeface="Microsoft YaHei"/>
+                          <a:latin typeface="Noto Sans CJK SC"/>
                         </a:rPr>
                         <a:t>跟踪遗漏、误报、修正原因，而不只看是否生成成功</a:t>
                       </a:r>
@@ -8825,7 +8825,7 @@
                           <a:solidFill>
                             <a:srgbClr val="1E293B"/>
                           </a:solidFill>
-                          <a:latin typeface="Microsoft YaHei"/>
+                          <a:latin typeface="Noto Sans CJK SC"/>
                         </a:rPr>
                         <a:t>采用</a:t>
                       </a:r>
@@ -8848,7 +8848,7 @@
                           <a:solidFill>
                             <a:srgbClr val="1E293B"/>
                           </a:solidFill>
-                          <a:latin typeface="Microsoft YaHei"/>
+                          <a:latin typeface="Noto Sans CJK SC"/>
                         </a:rPr>
                         <a:t>实际使用频次 / 使用者</a:t>
                       </a:r>
@@ -8871,7 +8871,7 @@
                           <a:solidFill>
                             <a:srgbClr val="1E293B"/>
                           </a:solidFill>
-                          <a:latin typeface="Microsoft YaHei"/>
+                          <a:latin typeface="Noto Sans CJK SC"/>
                         </a:rPr>
                         <a:t>区分作者本人使用与独立团队使用，再判断可推广性</a:t>
                       </a:r>
@@ -8896,7 +8896,7 @@
                           <a:solidFill>
                             <a:srgbClr val="1E293B"/>
                           </a:solidFill>
-                          <a:latin typeface="Microsoft YaHei"/>
+                          <a:latin typeface="Noto Sans CJK SC"/>
                         </a:rPr>
                         <a:t>成本</a:t>
                       </a:r>
@@ -8919,7 +8919,7 @@
                           <a:solidFill>
                             <a:srgbClr val="1E293B"/>
                           </a:solidFill>
-                          <a:latin typeface="Microsoft YaHei"/>
+                          <a:latin typeface="Noto Sans CJK SC"/>
                         </a:rPr>
                         <a:t>维护 / 培训 / 评审投入</a:t>
                       </a:r>
@@ -8942,7 +8942,7 @@
                           <a:solidFill>
                             <a:srgbClr val="1E293B"/>
                           </a:solidFill>
-                          <a:latin typeface="Microsoft YaHei"/>
+                          <a:latin typeface="Noto Sans CJK SC"/>
                         </a:rPr>
                         <a:t>把维护和培训成本与节省一起评估，判断净价值</a:t>
                       </a:r>
@@ -9039,7 +9039,7 @@
                 <a:solidFill>
                   <a:srgbClr val="092540"/>
                 </a:solidFill>
-                <a:latin typeface="Microsoft YaHei"/>
+                <a:latin typeface="Noto Sans CJK SC"/>
               </a:rPr>
               <a:t>当前不宣称已测得的节省工时、改善百分比或 ROI。</a:t>
             </a:r>
@@ -9193,7 +9193,7 @@
                 <a:solidFill>
                   <a:srgbClr val="FFFFFF"/>
                 </a:solidFill>
-                <a:latin typeface="Microsoft YaHei"/>
+                <a:latin typeface="Noto Sans CJK SC"/>
               </a:rPr>
               <a:t>下一步与所需支持</a:t>
             </a:r>
@@ -9235,7 +9235,7 @@
                 <a:solidFill>
                   <a:srgbClr val="DCE9F7"/>
                 </a:solidFill>
-                <a:latin typeface="Microsoft YaHei"/>
+                <a:latin typeface="Noto Sans CJK SC"/>
               </a:rPr>
               <a:t>建议的小范围试点方案：先验证，再扩展</a:t>
             </a:r>
@@ -9320,7 +9320,7 @@
                 <a:solidFill>
                   <a:srgbClr val="5A6573"/>
                 </a:solidFill>
-                <a:latin typeface="Microsoft YaHei"/>
+                <a:latin typeface="Noto Sans CJK SC"/>
               </a:rPr>
               <a:t>Ray Liu · September 2026</a:t>
             </a:r>
@@ -9362,7 +9362,7 @@
                 <a:solidFill>
                   <a:srgbClr val="5A6573"/>
                 </a:solidFill>
-                <a:latin typeface="Microsoft YaHei"/>
+                <a:latin typeface="Noto Sans CJK SC"/>
               </a:rPr>
               <a:t>6</a:t>
             </a:r>
@@ -9492,7 +9492,7 @@
                 <a:solidFill>
                   <a:srgbClr val="092540"/>
                 </a:solidFill>
-                <a:latin typeface="Microsoft YaHei"/>
+                <a:latin typeface="Noto Sans CJK SC"/>
               </a:rPr>
               <a:t>建议试点步骤</a:t>
             </a:r>
@@ -9534,7 +9534,7 @@
                 <a:solidFill>
                   <a:srgbClr val="1E293B"/>
                 </a:solidFill>
-                <a:latin typeface="Microsoft YaHei"/>
+                <a:latin typeface="Noto Sans CJK SC"/>
               </a:rPr>
               <a:t>选择规则稳定、频率较高的试点任务，并指定试点负责人和验收负责人</a:t>
             </a:r>
@@ -9553,7 +9553,7 @@
                 <a:solidFill>
                   <a:srgbClr val="1E293B"/>
                 </a:solidFill>
-                <a:latin typeface="Microsoft YaHei"/>
+                <a:latin typeface="Noto Sans CJK SC"/>
               </a:rPr>
               <a:t>准备经过批准的合成或脱敏示例，避免使用专有客户数据</a:t>
             </a:r>
@@ -9572,7 +9572,7 @@
                 <a:solidFill>
                   <a:srgbClr val="1E293B"/>
                 </a:solidFill>
-                <a:latin typeface="Microsoft YaHei"/>
+                <a:latin typeface="Noto Sans CJK SC"/>
               </a:rPr>
               <a:t>建立人工/工具基线，以及异常、复核和返工记录</a:t>
             </a:r>
@@ -9591,7 +9591,7 @@
                 <a:solidFill>
                   <a:srgbClr val="1E293B"/>
                 </a:solidFill>
-                <a:latin typeface="Microsoft YaHei"/>
+                <a:latin typeface="Noto Sans CJK SC"/>
               </a:rPr>
               <a:t>按约定验收标准评估效率、质量和维护成本，再决定是否扩展</a:t>
             </a:r>
@@ -9721,7 +9721,7 @@
                 <a:solidFill>
                   <a:srgbClr val="092540"/>
                 </a:solidFill>
-                <a:latin typeface="Microsoft YaHei"/>
+                <a:latin typeface="Noto Sans CJK SC"/>
               </a:rPr>
               <a:t>需要的管理支持</a:t>
             </a:r>
@@ -9763,7 +9763,7 @@
                 <a:solidFill>
                   <a:srgbClr val="1E293B"/>
                 </a:solidFill>
-                <a:latin typeface="Microsoft YaHei"/>
+                <a:latin typeface="Noto Sans CJK SC"/>
               </a:rPr>
               <a:t>确认试点参与人员和业务窗口</a:t>
             </a:r>
@@ -9782,7 +9782,7 @@
                 <a:solidFill>
                   <a:srgbClr val="1E293B"/>
                 </a:solidFill>
-                <a:latin typeface="Microsoft YaHei"/>
+                <a:latin typeface="Noto Sans CJK SC"/>
               </a:rPr>
               <a:t>批准可用于演示和验证的样例范围</a:t>
             </a:r>
@@ -9801,7 +9801,7 @@
                 <a:solidFill>
                   <a:srgbClr val="1E293B"/>
                 </a:solidFill>
-                <a:latin typeface="Microsoft YaHei"/>
+                <a:latin typeface="Noto Sans CJK SC"/>
               </a:rPr>
               <a:t>安排结果复盘，统一判断是否进入下一阶段</a:t>
             </a:r>
@@ -9820,7 +9820,7 @@
                 <a:solidFill>
                   <a:srgbClr val="1E293B"/>
                 </a:solidFill>
-                <a:latin typeface="Microsoft YaHei"/>
+                <a:latin typeface="Noto Sans CJK SC"/>
               </a:rPr>
               <a:t>在扩展前明确哪些结论需要独立团队复核</a:t>
             </a:r>
@@ -9907,7 +9907,7 @@
                 <a:solidFill>
                   <a:srgbClr val="092540"/>
                 </a:solidFill>
-                <a:latin typeface="Microsoft YaHei"/>
+                <a:latin typeface="Noto Sans CJK SC"/>
               </a:rPr>
               <a:t>这是建议方案，尚未批准；扩展应建立在试点结果和约定验收标准之上。</a:t>
             </a:r>

</xml_diff>